<commit_message>
deletes cvs from data retrieve
</commit_message>
<xml_diff>
--- a/Presentations/Cryto Arbitrage P2.pptx
+++ b/Presentations/Cryto Arbitrage P2.pptx
@@ -28465,7 +28465,19 @@
                 <a:uFillTx/>
                 <a:latin typeface="Grandview"/>
               </a:rPr>
-              <a:t>Data Science Workshop: Crypto Arbitrage system</a:t>
+              <a:t>Data Science Workshop: Crypto Arbitrage o</a:t>
+            </a:r>
+            <a:r>
+              <a:rPr lang="en-IL" cap="all" spc="300" dirty="0">
+                <a:solidFill>
+                  <a:srgbClr val="FFFFFF"/>
+                </a:solidFill>
+                <a:highlight>
+                  <a:srgbClr val="000000"/>
+                </a:highlight>
+                <a:latin typeface="Grandview"/>
+              </a:rPr>
+              <a:t>racle</a:t>
             </a:r>
             <a:endParaRPr lang="en-US" sz="4400" b="0" u="none" strike="noStrike" dirty="0">
               <a:solidFill>
@@ -29978,7 +29990,7 @@
                 <a:effectLst/>
                 <a:latin typeface="Menlo" panose="020B0609030804020204" pitchFamily="49" charset="0"/>
               </a:rPr>
-              <a:t> calculations over time)</a:t>
+              <a:t> calculations)</a:t>
             </a:r>
           </a:p>
           <a:p>
@@ -30948,7 +30960,7 @@
             <a:pPr lvl="2"/>
             <a:r>
               <a:rPr lang="en-US" sz="1600" dirty="0"/>
-              <a:t>Low spreads != executable trades</a:t>
+              <a:t>Low spreads != executable trades (absolute value)</a:t>
             </a:r>
           </a:p>
           <a:p>
@@ -31215,7 +31227,7 @@
             <a:pPr lvl="1"/>
             <a:r>
               <a:rPr lang="en-US" sz="2000" dirty="0"/>
-              <a:t>Temporal features need sufficient history (5,10,30)</a:t>
+              <a:t>Temporal features need sufficient history (5,15,30)</a:t>
             </a:r>
           </a:p>
           <a:p>
@@ -31267,13 +31279,13 @@
           <p:nvPr>
             <p:extLst>
               <p:ext uri="{D42A27DB-BD31-4B8C-83A1-F6EECF244321}">
-                <p14:modId xmlns:p14="http://schemas.microsoft.com/office/powerpoint/2010/main" val="2060643611"/>
+                <p14:modId xmlns:p14="http://schemas.microsoft.com/office/powerpoint/2010/main" val="2937166984"/>
               </p:ext>
             </p:extLst>
           </p:nvPr>
         </p:nvGraphicFramePr>
         <p:xfrm>
-          <a:off x="6956385" y="4118043"/>
+          <a:off x="6956385" y="4372686"/>
           <a:ext cx="5023413" cy="2346960"/>
         </p:xfrm>
         <a:graphic>
@@ -31669,7 +31681,7 @@
         </p:nvSpPr>
         <p:spPr>
           <a:xfrm flipH="1">
-            <a:off x="8293261" y="3803291"/>
+            <a:off x="8258537" y="4019040"/>
             <a:ext cx="2106591" cy="314752"/>
           </a:xfrm>
           <a:prstGeom prst="rect">
@@ -31814,6 +31826,31 @@
               <a:uFillTx/>
               <a:latin typeface="Arial"/>
             </a:endParaRPr>
+          </a:p>
+        </p:txBody>
+      </p:sp>
+      <p:sp>
+        <p:nvSpPr>
+          <p:cNvPr id="2" name="Text Placeholder 1">
+            <a:extLst>
+              <a:ext uri="{FF2B5EF4-FFF2-40B4-BE49-F238E27FC236}">
+                <a16:creationId xmlns:a16="http://schemas.microsoft.com/office/drawing/2014/main" id="{C5BA8240-650A-8E03-F4A6-7AF1667DB460}"/>
+              </a:ext>
+            </a:extLst>
+          </p:cNvPr>
+          <p:cNvSpPr>
+            <a:spLocks noGrp="1"/>
+          </p:cNvSpPr>
+          <p:nvPr>
+            <p:ph type="body"/>
+          </p:nvPr>
+        </p:nvSpPr>
+        <p:spPr/>
+        <p:txBody>
+          <a:bodyPr/>
+          <a:lstStyle/>
+          <a:p>
+            <a:endParaRPr lang="en-IL"/>
           </a:p>
         </p:txBody>
       </p:sp>
@@ -34144,7 +34181,7 @@
               <a:buChar char="•"/>
             </a:pPr>
             <a:r>
-              <a:rPr lang="en-US" sz="2000" b="1" u="none" strike="noStrike" dirty="0">
+              <a:rPr lang="en-US" sz="2000" u="none" strike="noStrike" dirty="0">
                 <a:solidFill>
                   <a:schemeClr val="dk1"/>
                 </a:solidFill>
@@ -34171,7 +34208,7 @@
               <a:buChar char="•"/>
             </a:pPr>
             <a:r>
-              <a:rPr lang="en-US" sz="1600" b="1" dirty="0">
+              <a:rPr lang="en-US" sz="1600" dirty="0">
                 <a:solidFill>
                   <a:schemeClr val="dk1"/>
                 </a:solidFill>
@@ -34179,7 +34216,7 @@
               <a:t>Binance, Coinbase, Kraken, Bitfinex, </a:t>
             </a:r>
             <a:r>
-              <a:rPr lang="en-US" sz="1600" b="1" dirty="0" err="1">
+              <a:rPr lang="en-US" sz="1600" dirty="0" err="1">
                 <a:solidFill>
                   <a:schemeClr val="dk1"/>
                 </a:solidFill>
@@ -34187,14 +34224,14 @@
               <a:t>Gate.io</a:t>
             </a:r>
             <a:r>
-              <a:rPr lang="en-US" sz="1600" b="1" dirty="0">
+              <a:rPr lang="en-US" sz="1600" dirty="0">
                 <a:solidFill>
                   <a:schemeClr val="dk1"/>
                 </a:solidFill>
               </a:rPr>
               <a:t>, MEXC</a:t>
             </a:r>
-            <a:endParaRPr lang="en-US" sz="1600" b="1" u="none" strike="noStrike" dirty="0">
+            <a:endParaRPr lang="en-US" sz="1600" u="none" strike="noStrike" dirty="0">
               <a:solidFill>
                 <a:schemeClr val="dk1"/>
               </a:solidFill>
@@ -34218,7 +34255,7 @@
               <a:buFont typeface="Arial"/>
               <a:buChar char="•"/>
             </a:pPr>
-            <a:endParaRPr lang="en-US" sz="100" b="1" u="none" strike="noStrike" dirty="0">
+            <a:endParaRPr lang="en-US" sz="100" u="none" strike="noStrike" dirty="0">
               <a:solidFill>
                 <a:schemeClr val="dk1"/>
               </a:solidFill>
@@ -34243,7 +34280,7 @@
               <a:buChar char="•"/>
             </a:pPr>
             <a:r>
-              <a:rPr lang="en-US" sz="2000" b="1" u="none" strike="noStrike" dirty="0">
+              <a:rPr lang="en-US" sz="2000" u="none" strike="noStrike" dirty="0">
                 <a:solidFill>
                   <a:schemeClr val="dk1"/>
                 </a:solidFill>
@@ -34254,7 +34291,7 @@
               <a:t>6 Crypto</a:t>
             </a:r>
             <a:r>
-              <a:rPr lang="en-US" sz="2000" b="1" dirty="0">
+              <a:rPr lang="en-US" sz="2000" dirty="0">
                 <a:solidFill>
                   <a:schemeClr val="dk1"/>
                 </a:solidFill>
@@ -34279,7 +34316,7 @@
               <a:buChar char="•"/>
             </a:pPr>
             <a:r>
-              <a:rPr lang="en-US" sz="1600" b="1" u="none" strike="noStrike" dirty="0">
+              <a:rPr lang="en-US" sz="1600" u="none" strike="noStrike" dirty="0">
                 <a:solidFill>
                   <a:schemeClr val="dk1"/>
                 </a:solidFill>
@@ -34289,7 +34326,7 @@
               </a:rPr>
               <a:t>BTC, ETH, DOGE, LINK, SOL, XRP</a:t>
             </a:r>
-            <a:endParaRPr lang="en-US" sz="1600" b="1" dirty="0">
+            <a:endParaRPr lang="en-US" sz="1600" dirty="0">
               <a:solidFill>
                 <a:schemeClr val="dk1"/>
               </a:solidFill>
@@ -34312,7 +34349,7 @@
               <a:buChar char="•"/>
             </a:pPr>
             <a:r>
-              <a:rPr lang="en-US" sz="2000" b="1" u="none" strike="noStrike" dirty="0">
+              <a:rPr lang="en-US" sz="2000" u="none" strike="noStrike" dirty="0">
                 <a:solidFill>
                   <a:schemeClr val="dk1"/>
                 </a:solidFill>
@@ -34339,7 +34376,7 @@
               <a:buChar char="•"/>
             </a:pPr>
             <a:r>
-              <a:rPr lang="en-US" sz="1600" b="1" dirty="0">
+              <a:rPr lang="en-US" sz="1600" dirty="0">
                 <a:solidFill>
                   <a:schemeClr val="dk1"/>
                 </a:solidFill>
@@ -34364,7 +34401,7 @@
               <a:buChar char="•"/>
             </a:pPr>
             <a:r>
-              <a:rPr lang="en-US" sz="1600" b="1" u="none" strike="noStrike" dirty="0">
+              <a:rPr lang="en-US" sz="1600" u="none" strike="noStrike" dirty="0">
                 <a:solidFill>
                   <a:schemeClr val="dk1"/>
                 </a:solidFill>
@@ -34375,7 +34412,7 @@
               <a:t>P</a:t>
             </a:r>
             <a:r>
-              <a:rPr lang="en-US" sz="1600" b="1" dirty="0">
+              <a:rPr lang="en-US" sz="1600" dirty="0">
                 <a:solidFill>
                   <a:schemeClr val="dk1"/>
                 </a:solidFill>
@@ -34400,7 +34437,7 @@
               <a:buChar char="•"/>
             </a:pPr>
             <a:r>
-              <a:rPr lang="en-US" sz="2000" b="1" u="none" strike="noStrike" dirty="0">
+              <a:rPr lang="en-US" sz="2000" u="none" strike="noStrike" dirty="0">
                 <a:solidFill>
                   <a:schemeClr val="dk1"/>
                 </a:solidFill>
@@ -34424,7 +34461,7 @@
               </a:buClr>
               <a:buSzPct val="75000"/>
             </a:pPr>
-            <a:endParaRPr lang="en-US" sz="2000" b="1" u="none" strike="noStrike" dirty="0">
+            <a:endParaRPr lang="en-US" sz="2000" u="none" strike="noStrike" dirty="0">
               <a:solidFill>
                 <a:schemeClr val="dk1"/>
               </a:solidFill>
@@ -34448,7 +34485,7 @@
               <a:buFont typeface="Arial"/>
               <a:buChar char="•"/>
             </a:pPr>
-            <a:endParaRPr lang="en-US" sz="100" b="1" u="none" strike="noStrike" dirty="0">
+            <a:endParaRPr lang="en-US" sz="100" u="none" strike="noStrike" dirty="0">
               <a:solidFill>
                 <a:schemeClr val="dk1"/>
               </a:solidFill>
@@ -34470,7 +34507,7 @@
               </a:buClr>
               <a:buSzPct val="75000"/>
             </a:pPr>
-            <a:endParaRPr lang="en-US" sz="100" b="1" u="none" strike="noStrike" dirty="0">
+            <a:endParaRPr lang="en-US" sz="100" u="none" strike="noStrike" dirty="0">
               <a:solidFill>
                 <a:srgbClr val="000000"/>
               </a:solidFill>
@@ -34623,7 +34660,7 @@
               <a:buChar char="•"/>
             </a:pPr>
             <a:r>
-              <a:rPr lang="en-US" sz="2000" b="1" u="none" strike="noStrike" dirty="0">
+              <a:rPr lang="en-US" sz="2000" u="none" strike="noStrike" dirty="0">
                 <a:solidFill>
                   <a:schemeClr val="dk1"/>
                 </a:solidFill>
@@ -34650,7 +34687,7 @@
               <a:buChar char="•"/>
             </a:pPr>
             <a:r>
-              <a:rPr lang="en-US" sz="1600" b="1" u="none" strike="noStrike" dirty="0">
+              <a:rPr lang="en-US" sz="1600" u="none" strike="noStrike" dirty="0">
                 <a:solidFill>
                   <a:schemeClr val="dk1"/>
                 </a:solidFill>
@@ -34661,7 +34698,7 @@
               <a:t>Time-</a:t>
             </a:r>
             <a:r>
-              <a:rPr lang="en-US" sz="1600" b="1" u="none" strike="noStrike" dirty="0" err="1">
+              <a:rPr lang="en-US" sz="1600" u="none" strike="noStrike" dirty="0" err="1">
                 <a:solidFill>
                   <a:schemeClr val="dk1"/>
                 </a:solidFill>
@@ -34672,7 +34709,7 @@
               <a:t>synchornzied</a:t>
             </a:r>
             <a:r>
-              <a:rPr lang="en-US" sz="1600" b="1" u="none" strike="noStrike" dirty="0">
+              <a:rPr lang="en-US" sz="1600" u="none" strike="noStrike" dirty="0">
                 <a:solidFill>
                   <a:schemeClr val="dk1"/>
                 </a:solidFill>
@@ -34683,7 +34720,7 @@
               <a:t> across exchanges (convert</a:t>
             </a:r>
             <a:r>
-              <a:rPr lang="en-US" sz="1600" b="1" dirty="0">
+              <a:rPr lang="en-US" sz="1600" dirty="0">
                 <a:solidFill>
                   <a:schemeClr val="dk1"/>
                 </a:solidFill>
@@ -34692,7 +34729,7 @@
               <a:t>ed</a:t>
             </a:r>
             <a:r>
-              <a:rPr lang="en-US" sz="1600" b="1" u="none" strike="noStrike" dirty="0">
+              <a:rPr lang="en-US" sz="1600" u="none" strike="noStrike" dirty="0">
                 <a:solidFill>
                   <a:schemeClr val="dk1"/>
                 </a:solidFill>
@@ -34719,7 +34756,7 @@
               <a:buChar char="•"/>
             </a:pPr>
             <a:r>
-              <a:rPr lang="en-US" sz="1600" b="1" u="none" strike="noStrike" dirty="0">
+              <a:rPr lang="en-US" sz="1600" u="none" strike="noStrike" dirty="0">
                 <a:solidFill>
                   <a:schemeClr val="dk1"/>
                 </a:solidFill>
@@ -34745,7 +34782,7 @@
               <a:buFont typeface="Arial"/>
               <a:buChar char="•"/>
             </a:pPr>
-            <a:endParaRPr lang="en-US" sz="2000" b="1" u="none" strike="noStrike" dirty="0">
+            <a:endParaRPr lang="en-US" sz="2000" u="none" strike="noStrike" dirty="0">
               <a:solidFill>
                 <a:schemeClr val="dk1"/>
               </a:solidFill>
@@ -34769,7 +34806,7 @@
               <a:buFont typeface="Arial"/>
               <a:buChar char="•"/>
             </a:pPr>
-            <a:endParaRPr lang="en-US" sz="2000" b="1" dirty="0">
+            <a:endParaRPr lang="en-US" sz="2000" dirty="0">
               <a:solidFill>
                 <a:schemeClr val="dk1"/>
               </a:solidFill>
@@ -34789,7 +34826,7 @@
                 <a:tab pos="0" algn="l"/>
               </a:tabLst>
             </a:pPr>
-            <a:endParaRPr lang="en-US" sz="2000" b="1" u="none" strike="noStrike" dirty="0">
+            <a:endParaRPr lang="en-US" sz="2000" u="none" strike="noStrike" dirty="0">
               <a:solidFill>
                 <a:srgbClr val="000000"/>
               </a:solidFill>
@@ -34987,7 +35024,7 @@
               <a:buChar char="•"/>
             </a:pPr>
             <a:r>
-              <a:rPr lang="en-US" sz="1600" b="1" dirty="0">
+              <a:rPr lang="en-US" sz="1600" dirty="0">
                 <a:solidFill>
                   <a:schemeClr val="dk1"/>
                 </a:solidFill>
@@ -35012,7 +35049,7 @@
               <a:buChar char="•"/>
             </a:pPr>
             <a:r>
-              <a:rPr lang="en-US" sz="1400" b="1" dirty="0">
+              <a:rPr lang="en-US" sz="1400" dirty="0">
                 <a:solidFill>
                   <a:schemeClr val="dk1"/>
                 </a:solidFill>
@@ -35037,7 +35074,7 @@
               <a:buChar char="•"/>
             </a:pPr>
             <a:r>
-              <a:rPr lang="en-US" sz="1400" b="1" u="none" strike="noStrike" dirty="0">
+              <a:rPr lang="en-US" sz="1400" u="none" strike="noStrike" dirty="0">
                 <a:solidFill>
                   <a:schemeClr val="dk1"/>
                 </a:solidFill>
@@ -35048,7 +35085,7 @@
               <a:t>Some exchanges missing certain cryptocurren</a:t>
             </a:r>
             <a:r>
-              <a:rPr lang="en-US" sz="1400" b="1" dirty="0">
+              <a:rPr lang="en-US" sz="1400" dirty="0">
                 <a:solidFill>
                   <a:schemeClr val="dk1"/>
                 </a:solidFill>
@@ -35073,7 +35110,7 @@
               <a:buChar char="•"/>
             </a:pPr>
             <a:r>
-              <a:rPr lang="en-US" sz="1400" b="1" u="none" strike="noStrike" dirty="0">
+              <a:rPr lang="en-US" sz="1400" u="none" strike="noStrike" dirty="0">
                 <a:solidFill>
                   <a:schemeClr val="dk1"/>
                 </a:solidFill>
@@ -35100,7 +35137,7 @@
               <a:buChar char="•"/>
             </a:pPr>
             <a:r>
-              <a:rPr lang="en-US" sz="1600" b="1" dirty="0">
+              <a:rPr lang="en-US" sz="1600" dirty="0">
                 <a:solidFill>
                   <a:schemeClr val="dk1"/>
                 </a:solidFill>
@@ -35125,7 +35162,7 @@
               <a:buChar char="•"/>
             </a:pPr>
             <a:r>
-              <a:rPr lang="en-US" sz="1400" b="1" u="none" strike="noStrike" dirty="0">
+              <a:rPr lang="en-US" sz="1400" u="none" strike="noStrike" dirty="0">
                 <a:solidFill>
                   <a:schemeClr val="dk1"/>
                 </a:solidFill>
@@ -35136,7 +35173,7 @@
               <a:t>Ex</a:t>
             </a:r>
             <a:r>
-              <a:rPr lang="en-US" sz="1400" b="1" dirty="0">
+              <a:rPr lang="en-US" sz="1400" dirty="0">
                 <a:solidFill>
                   <a:schemeClr val="dk1"/>
                 </a:solidFill>
@@ -35145,7 +35182,7 @@
               <a:t>change-</a:t>
             </a:r>
             <a:r>
-              <a:rPr lang="en-US" sz="1400" b="1" dirty="0" err="1">
+              <a:rPr lang="en-US" sz="1400" dirty="0" err="1">
                 <a:solidFill>
                   <a:schemeClr val="dk1"/>
                 </a:solidFill>
@@ -35154,7 +35191,7 @@
               <a:t>specifc</a:t>
             </a:r>
             <a:r>
-              <a:rPr lang="en-US" sz="1400" b="1" dirty="0">
+              <a:rPr lang="en-US" sz="1400" dirty="0">
                 <a:solidFill>
                   <a:schemeClr val="dk1"/>
                 </a:solidFill>
@@ -35179,7 +35216,7 @@
               <a:buChar char="•"/>
             </a:pPr>
             <a:r>
-              <a:rPr lang="en-US" sz="1400" b="1" u="none" strike="noStrike" dirty="0">
+              <a:rPr lang="en-US" sz="1400" u="none" strike="noStrike" dirty="0">
                 <a:solidFill>
                   <a:schemeClr val="dk1"/>
                 </a:solidFill>
@@ -35206,7 +35243,7 @@
               <a:buChar char="•"/>
             </a:pPr>
             <a:r>
-              <a:rPr lang="en-US" sz="1600" b="1" u="none" strike="noStrike" dirty="0">
+              <a:rPr lang="en-US" sz="1600" u="none" strike="noStrike" dirty="0">
                 <a:solidFill>
                   <a:schemeClr val="dk1"/>
                 </a:solidFill>
@@ -35233,7 +35270,7 @@
               <a:buChar char="•"/>
             </a:pPr>
             <a:r>
-              <a:rPr lang="en-US" sz="1400" b="1" dirty="0">
+              <a:rPr lang="en-US" sz="1400" dirty="0">
                 <a:solidFill>
                   <a:schemeClr val="dk1"/>
                 </a:solidFill>
@@ -35242,7 +35279,7 @@
               <a:t>Missing values (</a:t>
             </a:r>
             <a:r>
-              <a:rPr lang="en-US" sz="1400" b="1" dirty="0" err="1">
+              <a:rPr lang="en-US" sz="1400" dirty="0" err="1">
                 <a:solidFill>
                   <a:schemeClr val="dk1"/>
                 </a:solidFill>
@@ -35251,7 +35288,7 @@
               <a:t>NaN</a:t>
             </a:r>
             <a:r>
-              <a:rPr lang="en-US" sz="1400" b="1" dirty="0">
+              <a:rPr lang="en-US" sz="1400" dirty="0">
                 <a:solidFill>
                   <a:schemeClr val="dk1"/>
                 </a:solidFill>
@@ -35276,7 +35313,7 @@
               <a:buChar char="•"/>
             </a:pPr>
             <a:r>
-              <a:rPr lang="en-US" sz="1400" b="1" dirty="0">
+              <a:rPr lang="en-US" sz="1400" dirty="0">
                 <a:solidFill>
                   <a:schemeClr val="dk1"/>
                 </a:solidFill>
@@ -35284,7 +35321,7 @@
               </a:rPr>
               <a:t>Volume discrepancies across exchanges</a:t>
             </a:r>
-            <a:endParaRPr lang="en-US" sz="1400" b="1" u="none" strike="noStrike" dirty="0">
+            <a:endParaRPr lang="en-US" sz="1400" u="none" strike="noStrike" dirty="0">
               <a:solidFill>
                 <a:schemeClr val="dk1"/>
               </a:solidFill>
@@ -35308,7 +35345,7 @@
               <a:buFont typeface="Arial"/>
               <a:buChar char="•"/>
             </a:pPr>
-            <a:endParaRPr lang="en-US" sz="1600" b="1" dirty="0">
+            <a:endParaRPr lang="en-US" sz="1600" dirty="0">
               <a:solidFill>
                 <a:schemeClr val="dk1"/>
               </a:solidFill>
@@ -35328,7 +35365,7 @@
                 <a:tab pos="0" algn="l"/>
               </a:tabLst>
             </a:pPr>
-            <a:endParaRPr lang="en-US" sz="1600" b="1" u="none" strike="noStrike" dirty="0">
+            <a:endParaRPr lang="en-US" sz="1600" u="none" strike="noStrike" dirty="0">
               <a:solidFill>
                 <a:srgbClr val="000000"/>
               </a:solidFill>

</xml_diff>